<commit_message>
Update IRT dichotomous items slides and R script
Co-Authored-By: Claude Opus 4.6 <noreply@anthropic.com>
</commit_message>
<xml_diff>
--- a/IRT Models for Dichotomously Scored Items/Presentation Slides/4_TCCs_Test Information_SEM Functions.pptx
+++ b/IRT Models for Dichotomously Scored Items/Presentation Slides/4_TCCs_Test Information_SEM Functions.pptx
@@ -5,7 +5,7 @@
     <p:sldMasterId id="2147483648" r:id="rId1"/>
   </p:sldMasterIdLst>
   <p:notesMasterIdLst>
-    <p:notesMasterId r:id="rId15"/>
+    <p:notesMasterId r:id="rId16"/>
   </p:notesMasterIdLst>
   <p:sldIdLst>
     <p:sldId id="256" r:id="rId2"/>
@@ -19,8 +19,9 @@
     <p:sldId id="313" r:id="rId10"/>
     <p:sldId id="312" r:id="rId11"/>
     <p:sldId id="323" r:id="rId12"/>
-    <p:sldId id="315" r:id="rId13"/>
-    <p:sldId id="322" r:id="rId14"/>
+    <p:sldId id="324" r:id="rId13"/>
+    <p:sldId id="315" r:id="rId14"/>
+    <p:sldId id="322" r:id="rId15"/>
   </p:sldIdLst>
   <p:sldSz cx="12192000" cy="6858000"/>
   <p:notesSz cx="6858000" cy="9144000"/>
@@ -7276,6 +7277,158 @@
       </p:grpSpPr>
       <p:sp>
         <p:nvSpPr>
+          <p:cNvPr id="2" name="Title 1">
+            <a:extLst>
+              <a:ext uri="{FF2B5EF4-FFF2-40B4-BE49-F238E27FC236}">
+                <a16:creationId xmlns:a16="http://schemas.microsoft.com/office/drawing/2014/main" id="{ABAD9DCA-D052-AC08-DA31-891ADEFFFC60}"/>
+              </a:ext>
+            </a:extLst>
+          </p:cNvPr>
+          <p:cNvSpPr>
+            <a:spLocks noGrp="1"/>
+          </p:cNvSpPr>
+          <p:nvPr>
+            <p:ph type="title"/>
+          </p:nvPr>
+        </p:nvSpPr>
+        <p:spPr/>
+        <p:txBody>
+          <a:bodyPr/>
+          <a:lstStyle/>
+          <a:p>
+            <a:r>
+              <a:rPr lang="en-US"/>
+              <a:t>A Crib Sheet for Test Info values…</a:t>
+            </a:r>
+          </a:p>
+        </p:txBody>
+      </p:sp>
+      <p:sp>
+        <p:nvSpPr>
+          <p:cNvPr id="4" name="Slide Number Placeholder 3">
+            <a:extLst>
+              <a:ext uri="{FF2B5EF4-FFF2-40B4-BE49-F238E27FC236}">
+                <a16:creationId xmlns:a16="http://schemas.microsoft.com/office/drawing/2014/main" id="{DA057E3F-5D25-3BA2-35EC-C9B7FA2AAAE9}"/>
+              </a:ext>
+            </a:extLst>
+          </p:cNvPr>
+          <p:cNvSpPr>
+            <a:spLocks noGrp="1"/>
+          </p:cNvSpPr>
+          <p:nvPr>
+            <p:ph type="sldNum" sz="quarter" idx="12"/>
+          </p:nvPr>
+        </p:nvSpPr>
+        <p:spPr/>
+        <p:txBody>
+          <a:bodyPr/>
+          <a:lstStyle/>
+          <a:p>
+            <a:fld id="{0B97A0ED-0713-854E-AE67-C1B678B4A72A}" type="slidenum">
+              <a:rPr lang="en-US" smtClean="0"/>
+              <a:t>12</a:t>
+            </a:fld>
+            <a:endParaRPr lang="en-US"/>
+          </a:p>
+        </p:txBody>
+      </p:sp>
+      <p:pic>
+        <p:nvPicPr>
+          <p:cNvPr id="5" name="Picture 4">
+            <a:extLst>
+              <a:ext uri="{FF2B5EF4-FFF2-40B4-BE49-F238E27FC236}">
+                <a16:creationId xmlns:a16="http://schemas.microsoft.com/office/drawing/2014/main" id="{47C40F9E-46E1-C78E-71AC-03266D7CA253}"/>
+              </a:ext>
+            </a:extLst>
+          </p:cNvPr>
+          <p:cNvPicPr>
+            <a:picLocks noChangeAspect="1"/>
+          </p:cNvPicPr>
+          <p:nvPr/>
+        </p:nvPicPr>
+        <p:blipFill>
+          <a:blip r:embed="rId2"/>
+          <a:stretch>
+            <a:fillRect/>
+          </a:stretch>
+        </p:blipFill>
+        <p:spPr>
+          <a:xfrm>
+            <a:off x="1181865" y="1825128"/>
+            <a:ext cx="6666141" cy="4146014"/>
+          </a:xfrm>
+          <a:prstGeom prst="rect">
+            <a:avLst/>
+          </a:prstGeom>
+        </p:spPr>
+      </p:pic>
+      <p:sp>
+        <p:nvSpPr>
+          <p:cNvPr id="6" name="TextBox 5">
+            <a:extLst>
+              <a:ext uri="{FF2B5EF4-FFF2-40B4-BE49-F238E27FC236}">
+                <a16:creationId xmlns:a16="http://schemas.microsoft.com/office/drawing/2014/main" id="{63B58CC7-A94B-6E4F-C8D5-3D5809D84788}"/>
+              </a:ext>
+            </a:extLst>
+          </p:cNvPr>
+          <p:cNvSpPr txBox="1"/>
+          <p:nvPr/>
+        </p:nvSpPr>
+        <p:spPr>
+          <a:xfrm>
+            <a:off x="7689774" y="2882472"/>
+            <a:ext cx="3503364" cy="2031325"/>
+          </a:xfrm>
+          <a:prstGeom prst="rect">
+            <a:avLst/>
+          </a:prstGeom>
+          <a:noFill/>
+        </p:spPr>
+        <p:txBody>
+          <a:bodyPr wrap="square" rtlCol="0">
+            <a:spAutoFit/>
+          </a:bodyPr>
+          <a:lstStyle/>
+          <a:p>
+            <a:r>
+              <a:rPr lang="en-US"/>
+              <a:t>It’s typically the case that the SD of the theta distribution is constrained to be 1. In most large-scale standardized tests, we expect to have information at most locations of the theta that is at least = 9 or about .3. </a:t>
+            </a:r>
+          </a:p>
+        </p:txBody>
+      </p:sp>
+    </p:spTree>
+    <p:extLst>
+      <p:ext uri="{BB962C8B-B14F-4D97-AF65-F5344CB8AC3E}">
+        <p14:creationId xmlns:p14="http://schemas.microsoft.com/office/powerpoint/2010/main" val="3261491416"/>
+      </p:ext>
+    </p:extLst>
+  </p:cSld>
+  <p:clrMapOvr>
+    <a:masterClrMapping/>
+  </p:clrMapOvr>
+</p:sld>
+</file>
+
+<file path=ppt/slides/slide13.xml><?xml version="1.0" encoding="utf-8"?>
+<p:sld xmlns:a="http://schemas.openxmlformats.org/drawingml/2006/main" xmlns:r="http://schemas.openxmlformats.org/officeDocument/2006/relationships" xmlns:p="http://schemas.openxmlformats.org/presentationml/2006/main">
+  <p:cSld>
+    <p:spTree>
+      <p:nvGrpSpPr>
+        <p:cNvPr id="1" name=""/>
+        <p:cNvGrpSpPr/>
+        <p:nvPr/>
+      </p:nvGrpSpPr>
+      <p:grpSpPr>
+        <a:xfrm>
+          <a:off x="0" y="0"/>
+          <a:ext cx="0" cy="0"/>
+          <a:chOff x="0" y="0"/>
+          <a:chExt cx="0" cy="0"/>
+        </a:xfrm>
+      </p:grpSpPr>
+      <p:sp>
+        <p:nvSpPr>
           <p:cNvPr id="2" name="Title 1"/>
           <p:cNvSpPr>
             <a:spLocks noGrp="1"/>
@@ -7356,7 +7509,7 @@
           <a:p>
             <a:fld id="{0B97A0ED-0713-854E-AE67-C1B678B4A72A}" type="slidenum">
               <a:rPr lang="en-US" smtClean="0"/>
-              <a:t>12</a:t>
+              <a:t>13</a:t>
             </a:fld>
             <a:endParaRPr lang="en-US"/>
           </a:p>
@@ -7375,7 +7528,7 @@
 </p:sld>
 </file>
 
-<file path=ppt/slides/slide13.xml><?xml version="1.0" encoding="utf-8"?>
+<file path=ppt/slides/slide14.xml><?xml version="1.0" encoding="utf-8"?>
 <p:sld xmlns:a="http://schemas.openxmlformats.org/drawingml/2006/main" xmlns:r="http://schemas.openxmlformats.org/officeDocument/2006/relationships" xmlns:p="http://schemas.openxmlformats.org/presentationml/2006/main">
   <p:cSld>
     <p:spTree>
@@ -7456,7 +7609,7 @@
           <a:p>
             <a:r>
               <a:rPr lang="en-US" dirty="0"/>
-              <a:t>Use code in “Part 3” of in the file “lb_irt_012626.R”</a:t>
+              <a:t>Go to ”part 4” of the R Markdown file “TCC_Information_SEM.html”</a:t>
             </a:r>
           </a:p>
           <a:p>
@@ -7498,7 +7651,7 @@
           <a:p>
             <a:fld id="{0B97A0ED-0713-854E-AE67-C1B678B4A72A}" type="slidenum">
               <a:rPr lang="en-US" smtClean="0"/>
-              <a:t>13</a:t>
+              <a:t>14</a:t>
             </a:fld>
             <a:endParaRPr lang="en-US"/>
           </a:p>

</xml_diff>